<commit_message>
docs: refresh slides after the key-handling and quota corrections
</commit_message>
<xml_diff>
--- a/slides/2026-08-13-AI開發實戰.pptx
+++ b/slides/2026-08-13-AI開發實戰.pptx
@@ -12144,7 +12144,7 @@
                 <a:latin typeface="Menlo"/>
                 <a:ea typeface="Noto Sans TC"/>
               </a:rPr>
-              <a:t>2. 部署到 Vercel production，第一次問的設定全部用預設</a:t>
+              <a:t>2. 部署到 Vercel production；問到專案根目錄要選哪個，選 starter-kit，其餘用預設</a:t>
             </a:r>
           </a:p>
           <a:p>
@@ -12161,7 +12161,7 @@
                 <a:latin typeface="Menlo"/>
                 <a:ea typeface="Noto Sans TC"/>
               </a:rPr>
-              <a:t>3. 把 GROQ_API_KEY 加進環境變數（key 我貼給你，不要印在畫面上）</a:t>
+              <a:t>3. 要加 GROQ_API_KEY 的時候停下來告訴我，我自己去 Vercel 貼</a:t>
             </a:r>
           </a:p>
           <a:p>
@@ -12178,7 +12178,24 @@
                 <a:latin typeface="Menlo"/>
                 <a:ea typeface="Noto Sans TC"/>
               </a:rPr>
-              <a:t>4. 加完再部署一次讓 key 生效，不重跑不會生效</a:t>
+              <a:t>   不要問我 key、不要把它寫進任何檔案或印出來</a:t>
+            </a:r>
+          </a:p>
+          <a:p>
+            <a:pPr algn="l">
+              <a:lnSpc>
+                <a:spcPct val="118000"/>
+              </a:lnSpc>
+            </a:pPr>
+            <a:r>
+              <a:rPr sz="1500">
+                <a:solidFill>
+                  <a:srgbClr val="1A1A1A"/>
+                </a:solidFill>
+                <a:latin typeface="Menlo"/>
+                <a:ea typeface="Noto Sans TC"/>
+              </a:rPr>
+              <a:t>4. 我說加好了，你再部署一次 production 讓它生效</a:t>
             </a:r>
           </a:p>
           <a:p>
@@ -12279,7 +12296,7 @@
                 <a:latin typeface="Helvetica Neue"/>
                 <a:ea typeface="Noto Sans TC"/>
               </a:rPr>
-              <a:t>最貴的兩個坑寫在第 1 步跟第 4 步 —— 你不用記，但看到 404 就知道它跳過了</a:t>
+              <a:t>key 由你自己貼進 Vercel，不經過對話 —— 這是今天唯一一件不能外包的事</a:t>
             </a:r>
           </a:p>
         </p:txBody>
@@ -14848,8 +14865,8 @@
               </a:rPr>
               <a:t>他按送出 → ③ 拿你的 key
 去問 ④，要留紀錄才寫 ⑤
-他的瀏覽器永遠碰不到 ④⑤，
-也碰不到你的 key</a:t>
+今天這版，他的瀏覽器只打 ③
+未來前端若直接接 ⑤，就得靠 RLS 擋</a:t>
             </a:r>
           </a:p>
         </p:txBody>
@@ -17256,7 +17273,7 @@
                 <a:latin typeface="Helvetica Neue"/>
                 <a:ea typeface="Noto Sans TC"/>
               </a:rPr>
-              <a:t>✓「退回上一個能動的版本」→ 它自己會做</a:t>
+              <a:t>✓「先找出上一個能動的版本，說明要退哪些檔，等我確認」</a:t>
             </a:r>
           </a:p>
         </p:txBody>
@@ -18057,7 +18074,7 @@
                 <a:latin typeface="Helvetica Neue"/>
                 <a:ea typeface="Noto Sans TC"/>
               </a:rPr>
-              <a:t>AI 工程的五層演進 —— 你今天走過前三層</a:t>
+              <a:t>我用來教學的五層地圖（不是官方標準名詞）—— 你今天走過前三層</a:t>
             </a:r>
           </a:p>
         </p:txBody>
@@ -20551,7 +20568,7 @@
                 <a:latin typeface="Helvetica Neue"/>
                 <a:ea typeface="Noto Sans TC"/>
               </a:rPr>
-              <a:t>建議付費方案（免費版一天約 10 個 task）</a:t>
+              <a:t>建議付費方案，額度比較不會中途卡住</a:t>
             </a:r>
           </a:p>
         </p:txBody>
@@ -21442,8 +21459,8 @@
                 <a:latin typeface="Helvetica Neue"/>
                 <a:ea typeface="Noto Sans TC"/>
               </a:rPr>
-              <a:t>⚠️ 免費方案的 Codex 一天約 10 次（一次＝它完整跑一輪）—— 這堂課會很緊
-有 ChatGPT Plus 會順很多；沒有也做得完，額度用光看 QUICKSTART 的 Plan B</a:t>
+              <a:t>⚠️ Codex 額度依方案、模型、任務大小而變 —— 一次交辦一件小事最省
+快用完時改用較小的模型，或看 usage dashboard；真的用光看 QUICKSTART 的 Plan B</a:t>
             </a:r>
           </a:p>
         </p:txBody>

</xml_diff>

<commit_message>
docs: note the demo-site key check and the skip-it fallback in the opening notes
</commit_message>
<xml_diff>
--- a/slides/2026-08-13-AI開發實戰.pptx
+++ b/slides/2026-08-13-AI開發實戰.pptx
@@ -2182,6 +2182,21 @@
           <a:p>
             <a:r>
               <a:t>這裡真的打開一個做好的範例網站，現場輸入東西、AI 回話。先讓他們看到終點，後面所有步驟才有意義。</a:t>
+            </a:r>
+          </a:p>
+          <a:p>
+            <a:r>
+              <a:t>⚠️ 開場前先自己按一次送出確認它活著：starter-kit-kappa.vercel.app（Vercel 專案 starter-kit）。</a:t>
+            </a:r>
+          </a:p>
+          <a:p>
+            <a:r>
+              <a:t>若回「還沒設定 GROQ_API_KEY」= 那個專案的 key 過期了 —— Vercel → starter-kit → Settings → Environment Variables → GROQ_API_KEY（Production）→ 存檔 → Deployments → ⋯ → Redeploy，約 1 分鐘。</a:t>
+            </a:r>
+          </a:p>
+          <a:p>
+            <a:r>
+              <a:t>真的來不及就跳過示範，直接翻到下一頁講「今天結束你會有一個網址」，等他們自己的站活起來再回頭看 —— 不要在台上卡著等部署。</a:t>
             </a:r>
           </a:p>
         </p:txBody>

</xml_diff>

<commit_message>
docs: the key goes in a backend the student opens, not into the agent's chat
</commit_message>
<xml_diff>
--- a/slides/2026-08-13-AI開發實戰.pptx
+++ b/slides/2026-08-13-AI開發實戰.pptx
@@ -12284,8 +12284,8 @@
         </p:nvSpPr>
         <p:spPr>
           <a:xfrm>
-            <a:off x="914400" y="5925312"/>
-            <a:ext cx="10362895" cy="411480"/>
+            <a:off x="914400" y="5742432"/>
+            <a:ext cx="10362895" cy="603504"/>
           </a:xfrm>
           <a:prstGeom prst="rect">
             <a:avLst/>
@@ -12304,14 +12304,15 @@
               </a:lnSpc>
             </a:pPr>
             <a:r>
-              <a:rPr sz="1900" b="0">
+              <a:rPr sz="1800" b="0">
                 <a:solidFill>
                   <a:srgbClr val="8A8A85"/>
                 </a:solidFill>
                 <a:latin typeface="Helvetica Neue"/>
                 <a:ea typeface="Noto Sans TC"/>
               </a:rPr>
-              <a:t>key 由你自己貼進 Vercel，不經過對話 —— 這是今天唯一一件不能外包的事</a:t>
+              <a:t>key 你自己到後台貼，不經過 AI 對話 —— 這是今天唯一不能外包的事
+網站 → Vercel 專案 Settings → Environment Variables　｜　排程 → GitHub repo Settings → Secrets and variables → Actions</a:t>
             </a:r>
           </a:p>
         </p:txBody>

</xml_diff>

<commit_message>
docs: everyone builds the same shape, they only choose what it organises
</commit_message>
<xml_diff>
--- a/slides/2026-08-13-AI開發實戰.pptx
+++ b/slides/2026-08-13-AI開發實戰.pptx
@@ -1040,22 +1040,22 @@
           <a:lstStyle/>
           <a:p>
             <a:r>
-              <a:t>巡場只問一句：你今天要帶走的那一塊，是什麼？做完能解決你哪個痛點？</a:t>
-            </a:r>
-          </a:p>
-          <a:p>
-            <a:r>
-              <a:t>台下大多是學生／研究生／剛畢業，別用「你公司的工作流程」舉例 —— 他們接不上。</a:t>
-            </a:r>
-          </a:p>
-          <a:p>
-            <a:r>
-              <a:t>給得出來的題目：讀論文摘要整理、上課筆記整理成待辦、社團活動報名表彙整、</a:t>
-            </a:r>
-          </a:p>
-          <a:p>
-            <a:r>
-              <a:t>履歷條列改寫、實習週報草稿、讀書會分工表 —— 都是一個輸入框就能做的形狀。</a:t>
+              <a:t>重點是把野心壓下來：形狀不變（一個輸入框、一次 AI 呼叫、一張表），</a:t>
+            </a:r>
+          </a:p>
+          <a:p>
+            <a:r>
+              <a:t>只換「整理什麼」跟「哪幾欄」—— 這樣每個人 25 分鐘都寫得出 SPEC，也真的做得完。</a:t>
+            </a:r>
+          </a:p>
+          <a:p>
+            <a:r>
+              <a:t>巡場只問一句：你要它整理什麼？輸出哪幾欄？講得出來就可以動手了。</a:t>
+            </a:r>
+          </a:p>
+          <a:p>
+            <a:r>
+              <a:t>有人想做更大的（要登入、要資料庫、要多步驟）→ 記在紙上當作業，今天不做。</a:t>
             </a:r>
           </a:p>
         </p:txBody>
@@ -11186,8 +11186,8 @@
         </p:nvSpPr>
         <p:spPr>
           <a:xfrm>
-            <a:off x="10454335" y="6144768"/>
-            <a:ext cx="822960" cy="310896"/>
+            <a:off x="914400" y="1517904"/>
+            <a:ext cx="10362895" cy="457200"/>
           </a:xfrm>
           <a:prstGeom prst="rect">
             <a:avLst/>
@@ -11200,6 +11200,46 @@
           </a:bodyPr>
           <a:lstStyle/>
           <a:p>
+            <a:pPr algn="l">
+              <a:lnSpc>
+                <a:spcPct val="120000"/>
+              </a:lnSpc>
+            </a:pPr>
+            <a:r>
+              <a:rPr sz="2400" b="0">
+                <a:solidFill>
+                  <a:srgbClr val="4A4A4A"/>
+                </a:solidFill>
+                <a:latin typeface="Helvetica Neue"/>
+                <a:ea typeface="Noto Sans TC"/>
+              </a:rPr>
+              <a:t>全班同一個形狀，你只換它幫你整理什麼</a:t>
+            </a:r>
+          </a:p>
+        </p:txBody>
+      </p:sp>
+      <p:sp>
+        <p:nvSpPr>
+          <p:cNvPr id="5" name="TextBox 4"/>
+          <p:cNvSpPr txBox="1"/>
+          <p:nvPr/>
+        </p:nvSpPr>
+        <p:spPr>
+          <a:xfrm>
+            <a:off x="10454335" y="6144768"/>
+            <a:ext cx="822960" cy="310896"/>
+          </a:xfrm>
+          <a:prstGeom prst="rect">
+            <a:avLst/>
+          </a:prstGeom>
+          <a:noFill/>
+        </p:spPr>
+        <p:txBody>
+          <a:bodyPr wrap="square" lIns="0" rIns="0" tIns="0" bIns="0" anchor="t">
+            <a:spAutoFit/>
+          </a:bodyPr>
+          <a:lstStyle/>
+          <a:p>
             <a:pPr algn="r">
               <a:lnSpc>
                 <a:spcPct val="100000"/>
@@ -11220,14 +11260,14 @@
       </p:sp>
       <p:sp>
         <p:nvSpPr>
-          <p:cNvPr id="5" name="Rounded Rectangle 4"/>
+          <p:cNvPr id="6" name="Rounded Rectangle 5"/>
           <p:cNvSpPr/>
           <p:nvPr/>
         </p:nvSpPr>
         <p:spPr>
           <a:xfrm>
             <a:off x="914400" y="2157984"/>
-            <a:ext cx="10362895" cy="472440"/>
+            <a:ext cx="10362895" cy="557784"/>
           </a:xfrm>
           <a:prstGeom prst="roundRect">
             <a:avLst>
@@ -11266,13 +11306,13 @@
       </p:sp>
       <p:sp>
         <p:nvSpPr>
-          <p:cNvPr id="6" name="Oval 5"/>
+          <p:cNvPr id="7" name="Oval 6"/>
           <p:cNvSpPr/>
           <p:nvPr/>
         </p:nvSpPr>
         <p:spPr>
           <a:xfrm>
-            <a:off x="1152144" y="2202180"/>
+            <a:off x="1152144" y="2244852"/>
             <a:ext cx="438912" cy="438912"/>
           </a:xfrm>
           <a:prstGeom prst="ellipse">
@@ -11324,14 +11364,14 @@
       </p:sp>
       <p:sp>
         <p:nvSpPr>
-          <p:cNvPr id="7" name="TextBox 6"/>
+          <p:cNvPr id="8" name="TextBox 7"/>
           <p:cNvSpPr txBox="1"/>
           <p:nvPr/>
         </p:nvSpPr>
         <p:spPr>
           <a:xfrm>
             <a:off x="1810512" y="2139696"/>
-            <a:ext cx="8625535" cy="563880"/>
+            <a:ext cx="8625535" cy="649224"/>
           </a:xfrm>
           <a:prstGeom prst="rect">
             <a:avLst/>
@@ -11350,28 +11390,28 @@
               </a:lnSpc>
             </a:pPr>
             <a:r>
-              <a:rPr sz="2400" b="1">
+              <a:rPr sz="2200" b="1">
                 <a:solidFill>
                   <a:srgbClr val="1A1A1A"/>
                 </a:solidFill>
                 <a:latin typeface="Helvetica Neue"/>
                 <a:ea typeface="Noto Sans TC"/>
               </a:rPr>
-              <a:t>想一件你每週都要重複做、很煩的事（作業／報告／社團行政都算）</a:t>
-            </a:r>
-          </a:p>
-        </p:txBody>
-      </p:sp>
-      <p:sp>
-        <p:nvSpPr>
-          <p:cNvPr id="8" name="Rounded Rectangle 7"/>
+              <a:t>形狀固定：貼一段亂七八糟的文字 → AI 整理成一張表格</a:t>
+            </a:r>
+          </a:p>
+        </p:txBody>
+      </p:sp>
+      <p:sp>
+        <p:nvSpPr>
+          <p:cNvPr id="9" name="Rounded Rectangle 8"/>
           <p:cNvSpPr/>
           <p:nvPr/>
         </p:nvSpPr>
         <p:spPr>
           <a:xfrm>
-            <a:off x="914400" y="2721864"/>
-            <a:ext cx="10362895" cy="472440"/>
+            <a:off x="914400" y="2807208"/>
+            <a:ext cx="10362895" cy="557784"/>
           </a:xfrm>
           <a:prstGeom prst="roundRect">
             <a:avLst>
@@ -11410,13 +11450,13 @@
       </p:sp>
       <p:sp>
         <p:nvSpPr>
-          <p:cNvPr id="9" name="Oval 8"/>
+          <p:cNvPr id="10" name="Oval 9"/>
           <p:cNvSpPr/>
           <p:nvPr/>
         </p:nvSpPr>
         <p:spPr>
           <a:xfrm>
-            <a:off x="1152144" y="2766059"/>
+            <a:off x="1152144" y="2894076"/>
             <a:ext cx="438912" cy="438912"/>
           </a:xfrm>
           <a:prstGeom prst="ellipse">
@@ -11468,14 +11508,14 @@
       </p:sp>
       <p:sp>
         <p:nvSpPr>
-          <p:cNvPr id="10" name="TextBox 9"/>
+          <p:cNvPr id="11" name="TextBox 10"/>
           <p:cNvSpPr txBox="1"/>
           <p:nvPr/>
         </p:nvSpPr>
         <p:spPr>
           <a:xfrm>
-            <a:off x="1810512" y="2703576"/>
-            <a:ext cx="8625535" cy="563880"/>
+            <a:off x="1810512" y="2788920"/>
+            <a:ext cx="8625535" cy="649224"/>
           </a:xfrm>
           <a:prstGeom prst="rect">
             <a:avLst/>
@@ -11494,28 +11534,28 @@
               </a:lnSpc>
             </a:pPr>
             <a:r>
-              <a:rPr sz="2400" b="1">
+              <a:rPr sz="2200" b="1">
                 <a:solidFill>
                   <a:srgbClr val="1A1A1A"/>
                 </a:solidFill>
                 <a:latin typeface="Helvetica Neue"/>
                 <a:ea typeface="Noto Sans TC"/>
               </a:rPr>
-              <a:t>開 ChatGPT / Claude 新對話 → 貼訪談員 prompt</a:t>
-            </a:r>
-          </a:p>
-        </p:txBody>
-      </p:sp>
-      <p:sp>
-        <p:nvSpPr>
-          <p:cNvPr id="11" name="Rounded Rectangle 10"/>
+              <a:t>你只決定兩件事：整理「什麼」、輸出「哪幾欄」</a:t>
+            </a:r>
+          </a:p>
+        </p:txBody>
+      </p:sp>
+      <p:sp>
+        <p:nvSpPr>
+          <p:cNvPr id="12" name="Rounded Rectangle 11"/>
           <p:cNvSpPr/>
           <p:nvPr/>
         </p:nvSpPr>
         <p:spPr>
           <a:xfrm>
-            <a:off x="914400" y="3285744"/>
-            <a:ext cx="10362895" cy="472440"/>
+            <a:off x="914400" y="3456432"/>
+            <a:ext cx="10362895" cy="557784"/>
           </a:xfrm>
           <a:prstGeom prst="roundRect">
             <a:avLst>
@@ -11554,13 +11594,13 @@
       </p:sp>
       <p:sp>
         <p:nvSpPr>
-          <p:cNvPr id="12" name="Oval 11"/>
+          <p:cNvPr id="13" name="Oval 12"/>
           <p:cNvSpPr/>
           <p:nvPr/>
         </p:nvSpPr>
         <p:spPr>
           <a:xfrm>
-            <a:off x="1152144" y="3329940"/>
+            <a:off x="1152144" y="3543300"/>
             <a:ext cx="438912" cy="438912"/>
           </a:xfrm>
           <a:prstGeom prst="ellipse">
@@ -11612,14 +11652,14 @@
       </p:sp>
       <p:sp>
         <p:nvSpPr>
-          <p:cNvPr id="13" name="TextBox 12"/>
+          <p:cNvPr id="14" name="TextBox 13"/>
           <p:cNvSpPr txBox="1"/>
           <p:nvPr/>
         </p:nvSpPr>
         <p:spPr>
           <a:xfrm>
-            <a:off x="1810512" y="3267456"/>
-            <a:ext cx="8625535" cy="563880"/>
+            <a:off x="1810512" y="3438144"/>
+            <a:ext cx="8625535" cy="649224"/>
           </a:xfrm>
           <a:prstGeom prst="rect">
             <a:avLst/>
@@ -11638,28 +11678,28 @@
               </a:lnSpc>
             </a:pPr>
             <a:r>
-              <a:rPr sz="2400" b="1">
+              <a:rPr sz="2200" b="1">
                 <a:solidFill>
                   <a:srgbClr val="1A1A1A"/>
                 </a:solidFill>
                 <a:latin typeface="Helvetica Neue"/>
                 <a:ea typeface="Noto Sans TC"/>
               </a:rPr>
-              <a:t>它問你 6 題，你老實答</a:t>
-            </a:r>
-          </a:p>
-        </p:txBody>
-      </p:sp>
-      <p:sp>
-        <p:nvSpPr>
-          <p:cNvPr id="14" name="Rounded Rectangle 13"/>
+              <a:t>想不到就用預設：會議筆記 → 待辦 / 決議 / 待確認</a:t>
+            </a:r>
+          </a:p>
+        </p:txBody>
+      </p:sp>
+      <p:sp>
+        <p:nvSpPr>
+          <p:cNvPr id="15" name="Rounded Rectangle 14"/>
           <p:cNvSpPr/>
           <p:nvPr/>
         </p:nvSpPr>
         <p:spPr>
           <a:xfrm>
-            <a:off x="914400" y="3849623"/>
-            <a:ext cx="10362895" cy="472440"/>
+            <a:off x="914400" y="4105655"/>
+            <a:ext cx="10362895" cy="557784"/>
           </a:xfrm>
           <a:prstGeom prst="roundRect">
             <a:avLst>
@@ -11698,13 +11738,13 @@
       </p:sp>
       <p:sp>
         <p:nvSpPr>
-          <p:cNvPr id="15" name="Oval 14"/>
+          <p:cNvPr id="16" name="Oval 15"/>
           <p:cNvSpPr/>
           <p:nvPr/>
         </p:nvSpPr>
         <p:spPr>
           <a:xfrm>
-            <a:off x="1152144" y="3893819"/>
+            <a:off x="1152144" y="4192523"/>
             <a:ext cx="438912" cy="438912"/>
           </a:xfrm>
           <a:prstGeom prst="ellipse">
@@ -11756,14 +11796,14 @@
       </p:sp>
       <p:sp>
         <p:nvSpPr>
-          <p:cNvPr id="16" name="TextBox 15"/>
+          <p:cNvPr id="17" name="TextBox 16"/>
           <p:cNvSpPr txBox="1"/>
           <p:nvPr/>
         </p:nvSpPr>
         <p:spPr>
           <a:xfrm>
-            <a:off x="1810512" y="3831335"/>
-            <a:ext cx="8625535" cy="563880"/>
+            <a:off x="1810512" y="4087368"/>
+            <a:ext cx="8625535" cy="649224"/>
           </a:xfrm>
           <a:prstGeom prst="rect">
             <a:avLst/>
@@ -11782,28 +11822,28 @@
               </a:lnSpc>
             </a:pPr>
             <a:r>
-              <a:rPr sz="2400" b="1">
+              <a:rPr sz="2200" b="1">
                 <a:solidFill>
                   <a:srgbClr val="1A1A1A"/>
                 </a:solidFill>
                 <a:latin typeface="Helvetica Neue"/>
                 <a:ea typeface="Noto Sans TC"/>
               </a:rPr>
-              <a:t>拿到 PRD → 用 A-F 六格逐條 review</a:t>
-            </a:r>
-          </a:p>
-        </p:txBody>
-      </p:sp>
-      <p:sp>
-        <p:nvSpPr>
-          <p:cNvPr id="17" name="Rounded Rectangle 16"/>
+              <a:t>把這兩件事寫成三行，就是你今天的 SPEC.md</a:t>
+            </a:r>
+          </a:p>
+        </p:txBody>
+      </p:sp>
+      <p:sp>
+        <p:nvSpPr>
+          <p:cNvPr id="18" name="Rounded Rectangle 17"/>
           <p:cNvSpPr/>
           <p:nvPr/>
         </p:nvSpPr>
         <p:spPr>
           <a:xfrm>
-            <a:off x="914400" y="4413504"/>
-            <a:ext cx="10362895" cy="472440"/>
+            <a:off x="914400" y="4754879"/>
+            <a:ext cx="10362895" cy="557784"/>
           </a:xfrm>
           <a:prstGeom prst="roundRect">
             <a:avLst>
@@ -11842,13 +11882,13 @@
       </p:sp>
       <p:sp>
         <p:nvSpPr>
-          <p:cNvPr id="18" name="Oval 17"/>
+          <p:cNvPr id="19" name="Oval 18"/>
           <p:cNvSpPr/>
           <p:nvPr/>
         </p:nvSpPr>
         <p:spPr>
           <a:xfrm>
-            <a:off x="1152144" y="4457700"/>
+            <a:off x="1152144" y="4841748"/>
             <a:ext cx="438912" cy="438912"/>
           </a:xfrm>
           <a:prstGeom prst="ellipse">
@@ -11900,14 +11940,14 @@
       </p:sp>
       <p:sp>
         <p:nvSpPr>
-          <p:cNvPr id="19" name="TextBox 18"/>
+          <p:cNvPr id="20" name="TextBox 19"/>
           <p:cNvSpPr txBox="1"/>
           <p:nvPr/>
         </p:nvSpPr>
         <p:spPr>
           <a:xfrm>
-            <a:off x="1810512" y="4395216"/>
-            <a:ext cx="8625535" cy="563880"/>
+            <a:off x="1810512" y="4736592"/>
+            <a:ext cx="8625535" cy="649224"/>
           </a:xfrm>
           <a:prstGeom prst="rect">
             <a:avLst/>
@@ -11926,172 +11966,28 @@
               </a:lnSpc>
             </a:pPr>
             <a:r>
-              <a:rPr sz="2400" b="1">
+              <a:rPr sz="2200" b="1">
                 <a:solidFill>
                   <a:srgbClr val="1A1A1A"/>
                 </a:solidFill>
                 <a:latin typeface="Helvetica Neue"/>
                 <a:ea typeface="Noto Sans TC"/>
               </a:rPr>
-              <a:t>不對的地方叫它改（一次只講一節）</a:t>
-            </a:r>
-          </a:p>
-        </p:txBody>
-      </p:sp>
-      <p:sp>
-        <p:nvSpPr>
-          <p:cNvPr id="20" name="Rounded Rectangle 19"/>
-          <p:cNvSpPr/>
-          <p:nvPr/>
-        </p:nvSpPr>
-        <p:spPr>
-          <a:xfrm>
-            <a:off x="914400" y="4977384"/>
-            <a:ext cx="10362895" cy="472440"/>
-          </a:xfrm>
-          <a:prstGeom prst="roundRect">
-            <a:avLst>
-              <a:gd name="adj" fmla="val 22000"/>
-            </a:avLst>
-          </a:prstGeom>
-          <a:solidFill>
-            <a:srgbClr val="FDEFE4"/>
-          </a:solidFill>
-          <a:ln>
-            <a:noFill/>
-          </a:ln>
-          <a:effectLst/>
-        </p:spPr>
-        <p:style>
-          <a:lnRef idx="1">
-            <a:schemeClr val="accent1"/>
-          </a:lnRef>
-          <a:fillRef idx="3">
-            <a:schemeClr val="accent1"/>
-          </a:fillRef>
-          <a:effectRef idx="2">
-            <a:schemeClr val="accent1"/>
-          </a:effectRef>
-          <a:fontRef idx="minor">
-            <a:schemeClr val="lt1"/>
-          </a:fontRef>
-        </p:style>
-        <p:txBody>
-          <a:bodyPr rtlCol="0" anchor="ctr" wrap="square"/>
-          <a:lstStyle/>
-          <a:p>
-            <a:pPr algn="ctr"/>
-          </a:p>
-        </p:txBody>
-      </p:sp>
-      <p:sp>
-        <p:nvSpPr>
-          <p:cNvPr id="21" name="Oval 20"/>
-          <p:cNvSpPr/>
-          <p:nvPr/>
-        </p:nvSpPr>
-        <p:spPr>
-          <a:xfrm>
-            <a:off x="1152144" y="5021580"/>
-            <a:ext cx="438912" cy="438912"/>
-          </a:xfrm>
-          <a:prstGeom prst="ellipse">
-            <a:avLst/>
-          </a:prstGeom>
-          <a:solidFill>
-            <a:srgbClr val="C2410C"/>
-          </a:solidFill>
-          <a:ln>
-            <a:noFill/>
-          </a:ln>
-          <a:effectLst/>
-        </p:spPr>
-        <p:style>
-          <a:lnRef idx="1">
-            <a:schemeClr val="accent1"/>
-          </a:lnRef>
-          <a:fillRef idx="3">
-            <a:schemeClr val="accent1"/>
-          </a:fillRef>
-          <a:effectRef idx="2">
-            <a:schemeClr val="accent1"/>
-          </a:effectRef>
-          <a:fontRef idx="minor">
-            <a:schemeClr val="lt1"/>
-          </a:fontRef>
-        </p:style>
-        <p:txBody>
-          <a:bodyPr rtlCol="0" anchor="ctr" wrap="square" lIns="0" rIns="0" tIns="54864" bIns="54864"/>
-          <a:lstStyle/>
-          <a:p>
-            <a:pPr algn="ctr">
-              <a:lnSpc>
-                <a:spcPct val="122000"/>
-              </a:lnSpc>
-            </a:pPr>
-            <a:r>
-              <a:rPr sz="2200" b="1">
-                <a:solidFill>
-                  <a:srgbClr val="FFFFFF"/>
-                </a:solidFill>
-                <a:latin typeface="Helvetica Neue"/>
-                <a:ea typeface="Noto Sans TC"/>
-              </a:rPr>
-              <a:t>6</a:t>
-            </a:r>
-          </a:p>
-        </p:txBody>
-      </p:sp>
-      <p:sp>
-        <p:nvSpPr>
-          <p:cNvPr id="22" name="TextBox 21"/>
+              <a:t>用 A-F 六格檢查一遍，特別是 F：三條驗收條件寫得出來嗎</a:t>
+            </a:r>
+          </a:p>
+        </p:txBody>
+      </p:sp>
+      <p:sp>
+        <p:nvSpPr>
+          <p:cNvPr id="21" name="TextBox 20"/>
           <p:cNvSpPr txBox="1"/>
           <p:nvPr/>
         </p:nvSpPr>
         <p:spPr>
           <a:xfrm>
-            <a:off x="1810512" y="4959096"/>
-            <a:ext cx="8625535" cy="563880"/>
-          </a:xfrm>
-          <a:prstGeom prst="rect">
-            <a:avLst/>
-          </a:prstGeom>
-          <a:noFill/>
-        </p:spPr>
-        <p:txBody>
-          <a:bodyPr wrap="square" lIns="0" rIns="0" tIns="0" bIns="0" anchor="ctr">
-            <a:spAutoFit/>
-          </a:bodyPr>
-          <a:lstStyle/>
-          <a:p>
-            <a:pPr algn="l">
-              <a:lnSpc>
-                <a:spcPct val="115000"/>
-              </a:lnSpc>
-            </a:pPr>
-            <a:r>
-              <a:rPr sz="2400" b="1">
-                <a:solidFill>
-                  <a:srgbClr val="1A1A1A"/>
-                </a:solidFill>
-                <a:latin typeface="Helvetica Neue"/>
-                <a:ea typeface="Noto Sans TC"/>
-              </a:rPr>
-              <a:t>存成你 repo 的 SPEC.md</a:t>
-            </a:r>
-          </a:p>
-        </p:txBody>
-      </p:sp>
-      <p:sp>
-        <p:nvSpPr>
-          <p:cNvPr id="23" name="TextBox 22"/>
-          <p:cNvSpPr txBox="1"/>
-          <p:nvPr/>
-        </p:nvSpPr>
-        <p:spPr>
-          <a:xfrm>
-            <a:off x="914400" y="5925312"/>
-            <a:ext cx="10362895" cy="411480"/>
+            <a:off x="914400" y="5760720"/>
+            <a:ext cx="10362895" cy="566928"/>
           </a:xfrm>
           <a:prstGeom prst="rect">
             <a:avLst/>
@@ -12110,14 +12006,15 @@
               </a:lnSpc>
             </a:pPr>
             <a:r>
-              <a:rPr sz="1900" b="0">
+              <a:rPr sz="1800" b="0">
                 <a:solidFill>
                   <a:srgbClr val="8A8A85"/>
                 </a:solidFill>
                 <a:latin typeface="Helvetica Neue"/>
                 <a:ea typeface="Noto Sans TC"/>
               </a:rPr>
-              <a:t>腦袋空白的人舉手 → 我給你暖身 prompt（repo 的 Prompt 2）</a:t>
+              <a:t>換個整理對象就是新東西：課堂筆記 → 重點／作業／要問老師的　·　客服訊息 → 急件／一般／可忽略
+要做更複雜的再用訪談員 prompt 產完整 PRD（repo 的 Prompt 1），今天先求做得完</a:t>
             </a:r>
           </a:p>
         </p:txBody>

</xml_diff>